<commit_message>
Add interactive demo web app and finalize submission materials
Add demo/, a Next.js + Cloudflare Workers app
(flight-arrival-delay-capstone) that serves the project as a shareable
site: live logistic-regression and linear-regression predictions
retrained from the notebook methodology (random state 42, a stratified
30,000-row sample, 60/20/20 split), plus the full 17-part report --
EDA, baseline/advanced model comparisons, clustering, and PCA --
rendered from the notebook's exported plots and results.

Also update Capstone_ArrivalDelay.ipynb and the presentation deck, add
ML_Tuwaiq.pdf, and revise Project_Summary_Report.tex.
</commit_message>
<xml_diff>
--- a/ML Project Arrival Delay.pptx
+++ b/ML Project Arrival Delay.pptx
@@ -829,6 +829,10 @@
             <a:prstDash val="solid"/>
           </a:ln>
         </p:spPr>
+        <p:txBody>
+          <a:bodyPr/>
+          <a:p/>
+        </p:txBody>
       </p:sp>
       <p:sp>
         <p:nvSpPr>
@@ -856,6 +860,10 @@
             <a:prstDash val="solid"/>
           </a:ln>
         </p:spPr>
+        <p:txBody>
+          <a:bodyPr/>
+          <a:p/>
+        </p:txBody>
       </p:sp>
       <p:sp>
         <p:nvSpPr>
@@ -881,6 +889,10 @@
             <a:prstDash val="solid"/>
           </a:ln>
         </p:spPr>
+        <p:txBody>
+          <a:bodyPr/>
+          <a:p/>
+        </p:txBody>
       </p:sp>
       <p:sp>
         <p:nvSpPr>
@@ -906,6 +918,10 @@
             <a:prstDash val="solid"/>
           </a:ln>
         </p:spPr>
+        <p:txBody>
+          <a:bodyPr/>
+          <a:p/>
+        </p:txBody>
       </p:sp>
       <p:sp>
         <p:nvSpPr>
@@ -1067,6 +1083,10 @@
             <a:prstDash val="solid"/>
           </a:ln>
         </p:spPr>
+        <p:txBody>
+          <a:bodyPr/>
+          <a:p/>
+        </p:txBody>
       </p:sp>
       <p:sp>
         <p:nvSpPr>
@@ -1168,6 +1188,10 @@
             <a:prstDash val="solid"/>
           </a:ln>
         </p:spPr>
+        <p:txBody>
+          <a:bodyPr/>
+          <a:p/>
+        </p:txBody>
       </p:sp>
       <p:sp>
         <p:nvSpPr>
@@ -1202,7 +1226,7 @@
                 <a:ea typeface="IBM Plex Sans" pitchFamily="34" charset="-122"/>
                 <a:cs typeface="IBM Plex Sans" pitchFamily="34" charset="-120"/>
               </a:rPr>
-              <a:t>12</a:t>
+              <a:t>8</a:t>
             </a:r>
           </a:p>
         </p:txBody>
@@ -1269,6 +1293,10 @@
             <a:prstDash val="solid"/>
           </a:ln>
         </p:spPr>
+        <p:txBody>
+          <a:bodyPr/>
+          <a:p/>
+        </p:txBody>
       </p:sp>
       <p:sp>
         <p:nvSpPr>
@@ -1370,6 +1398,10 @@
             <a:prstDash val="solid"/>
           </a:ln>
         </p:spPr>
+        <p:txBody>
+          <a:bodyPr/>
+          <a:p/>
+        </p:txBody>
       </p:sp>
       <p:sp>
         <p:nvSpPr>
@@ -2873,7 +2905,7 @@
                 <a:ea typeface="IBM Plex Sans" pitchFamily="34" charset="-122"/>
                 <a:cs typeface="IBM Plex Sans" pitchFamily="34" charset="-120"/>
               </a:rPr>
-              <a:t>Twelve models, two problems</a:t>
+              <a:t>Eight models, two problems</a:t>
             </a:r>
           </a:p>
         </p:txBody>
@@ -2902,6 +2934,10 @@
             <a:prstDash val="solid"/>
           </a:ln>
         </p:spPr>
+        <p:txBody>
+          <a:bodyPr/>
+          <a:p/>
+        </p:txBody>
       </p:sp>
       <p:sp>
         <p:nvSpPr>
@@ -2936,7 +2972,7 @@
                 <a:ea typeface="IBM Plex Sans" pitchFamily="34" charset="-122"/>
                 <a:cs typeface="IBM Plex Sans" pitchFamily="34" charset="-120"/>
               </a:rPr>
-              <a:t>Six algorithms per target on one shared split</a:t>
+              <a:t>Four algorithms per target on one shared split</a:t>
             </a:r>
           </a:p>
         </p:txBody>
@@ -2974,17 +3010,21 @@
             </a:outerShdw>
           </a:effectLst>
         </p:spPr>
+        <p:txBody>
+          <a:bodyPr/>
+          <a:p/>
+        </p:txBody>
       </p:sp>
       <p:pic>
         <p:nvPicPr>
-          <p:cNvPr id="330" name="Picture 329" descr="plot_09.png"/>
+          <p:cNvPr id="336" name="Picture 335" descr="slide11_left_rocauc.png"/>
           <p:cNvPicPr>
             <a:picLocks noChangeAspect="1"/>
           </p:cNvPicPr>
           <p:nvPr/>
         </p:nvPicPr>
         <p:blipFill>
-          <a:blip r:embed="rId2"/>
+          <a:blip r:embed="rId4"/>
           <a:stretch>
             <a:fillRect/>
           </a:stretch>
@@ -3032,17 +3072,21 @@
             </a:outerShdw>
           </a:effectLst>
         </p:spPr>
+        <p:txBody>
+          <a:bodyPr/>
+          <a:p/>
+        </p:txBody>
       </p:sp>
       <p:pic>
         <p:nvPicPr>
-          <p:cNvPr id="331" name="Picture 330" descr="plot_10.png"/>
+          <p:cNvPr id="337" name="Picture 336" descr="slide11_right_r2.png"/>
           <p:cNvPicPr>
             <a:picLocks noChangeAspect="1"/>
           </p:cNvPicPr>
           <p:nvPr/>
         </p:nvPicPr>
         <p:blipFill>
-          <a:blip r:embed="rId3"/>
+          <a:blip r:embed="rId5"/>
           <a:stretch>
             <a:fillRect/>
           </a:stretch>
@@ -3166,6 +3210,10 @@
             </a:outerShdw>
           </a:effectLst>
         </p:spPr>
+        <p:txBody>
+          <a:bodyPr/>
+          <a:p/>
+        </p:txBody>
       </p:sp>
       <p:sp>
         <p:nvSpPr>
@@ -3191,6 +3239,10 @@
             <a:prstDash val="solid"/>
           </a:ln>
         </p:spPr>
+        <p:txBody>
+          <a:bodyPr/>
+          <a:p/>
+        </p:txBody>
       </p:sp>
       <p:sp>
         <p:nvSpPr>
@@ -3317,6 +3369,10 @@
             <a:prstDash val="solid"/>
           </a:ln>
         </p:spPr>
+        <p:txBody>
+          <a:bodyPr/>
+          <a:p/>
+        </p:txBody>
       </p:sp>
       <p:sp>
         <p:nvSpPr>
@@ -3389,17 +3445,21 @@
             </a:outerShdw>
           </a:effectLst>
         </p:spPr>
+        <p:txBody>
+          <a:bodyPr/>
+          <a:p/>
+        </p:txBody>
       </p:sp>
       <p:pic>
         <p:nvPicPr>
-          <p:cNvPr id="340" name="Picture 339" descr="plot_11.png"/>
+          <p:cNvPr id="347" name="Picture 346" descr="slide12_gap_bar.png"/>
           <p:cNvPicPr>
             <a:picLocks noChangeAspect="1"/>
           </p:cNvPicPr>
           <p:nvPr/>
         </p:nvPicPr>
         <p:blipFill>
-          <a:blip r:embed="rId2"/>
+          <a:blip r:embed="rId3"/>
           <a:stretch>
             <a:fillRect/>
           </a:stretch>
@@ -3447,6 +3507,10 @@
             </a:outerShdw>
           </a:effectLst>
         </p:spPr>
+        <p:txBody>
+          <a:bodyPr/>
+          <a:p/>
+        </p:txBody>
       </p:sp>
       <p:sp>
         <p:nvSpPr>
@@ -3472,6 +3536,10 @@
             <a:prstDash val="solid"/>
           </a:ln>
         </p:spPr>
+        <p:txBody>
+          <a:bodyPr/>
+          <a:p/>
+        </p:txBody>
       </p:sp>
       <p:sp>
         <p:nvSpPr>
@@ -3548,44 +3616,6 @@
                 <a:cs typeface="IBM Plex Sans" pitchFamily="34" charset="-120"/>
               </a:rPr>
               <a:t>Logistic  0.011</a:t>
-            </a:r>
-          </a:p>
-          <a:p>
-            <a:pPr indent="0" marL="0">
-              <a:spcAft>
-                <a:spcPts val="600"/>
-              </a:spcAft>
-              <a:buNone/>
-            </a:pPr>
-            <a:r>
-              <a:rPr lang="en-US" sz="1300" kern="0" dirty="0">
-                <a:solidFill>
-                  <a:srgbClr val="000000"/>
-                </a:solidFill>
-                <a:latin typeface="IBM Plex Sans" pitchFamily="34" charset="0"/>
-                <a:ea typeface="IBM Plex Sans" pitchFamily="34" charset="-122"/>
-                <a:cs typeface="IBM Plex Sans" pitchFamily="34" charset="-120"/>
-              </a:rPr>
-              <a:t>Decision Tree  0.022</a:t>
-            </a:r>
-          </a:p>
-          <a:p>
-            <a:pPr indent="0" marL="0">
-              <a:spcAft>
-                <a:spcPts val="600"/>
-              </a:spcAft>
-              <a:buNone/>
-            </a:pPr>
-            <a:r>
-              <a:rPr lang="en-US" sz="1300" kern="0" dirty="0">
-                <a:solidFill>
-                  <a:srgbClr val="000000"/>
-                </a:solidFill>
-                <a:latin typeface="IBM Plex Sans" pitchFamily="34" charset="0"/>
-                <a:ea typeface="IBM Plex Sans" pitchFamily="34" charset="-122"/>
-                <a:cs typeface="IBM Plex Sans" pitchFamily="34" charset="-120"/>
-              </a:rPr>
-              <a:t>Random Forest  0.025</a:t>
             </a:r>
           </a:p>
           <a:p>
@@ -3718,6 +3748,10 @@
             </a:outerShdw>
           </a:effectLst>
         </p:spPr>
+        <p:txBody>
+          <a:bodyPr/>
+          <a:p/>
+        </p:txBody>
       </p:sp>
       <p:sp>
         <p:nvSpPr>
@@ -3743,6 +3777,10 @@
             <a:prstDash val="solid"/>
           </a:ln>
         </p:spPr>
+        <p:txBody>
+          <a:bodyPr/>
+          <a:p/>
+        </p:txBody>
       </p:sp>
       <p:sp>
         <p:nvSpPr>
@@ -3917,7 +3955,7 @@
         <p:spPr>
           <a:xfrm>
             <a:off x="566928" y="1572768"/>
-            <a:ext cx="5440680" cy="3749039"/>
+            <a:ext cx="11073384" cy="3749039"/>
           </a:xfrm>
           <a:prstGeom prst="roundRect">
             <a:avLst>
@@ -3958,7 +3996,7 @@
         </p:blipFill>
         <p:spPr>
           <a:xfrm>
-            <a:off x="676656" y="1721629"/>
+            <a:off x="3493008" y="1721629"/>
             <a:ext cx="5221224" cy="3451317"/>
           </a:xfrm>
           <a:prstGeom prst="rect">
@@ -3968,64 +4006,6 @@
       </p:pic>
       <p:sp>
         <p:nvSpPr>
-          <p:cNvPr id="351" name="Card"/>
-          <p:cNvSpPr/>
-          <p:nvPr/>
-        </p:nvSpPr>
-        <p:spPr>
-          <a:xfrm>
-            <a:off x="6199632" y="1572768"/>
-            <a:ext cx="5440680" cy="3749039"/>
-          </a:xfrm>
-          <a:prstGeom prst="roundRect">
-            <a:avLst>
-              <a:gd name="adj" fmla="val 1951"/>
-            </a:avLst>
-          </a:prstGeom>
-          <a:solidFill>
-            <a:srgbClr val="FFFFFF"/>
-          </a:solidFill>
-          <a:ln w="12700">
-            <a:solidFill>
-              <a:srgbClr val="FFFFFF"/>
-            </a:solidFill>
-            <a:prstDash val="solid"/>
-          </a:ln>
-          <a:effectLst>
-            <a:outerShdw sx="100000" sy="100000" kx="0" ky="0" algn="bl" rotWithShape="0" blurRad="114300" dist="12700" dir="5400000">
-              <a:srgbClr val="B9A9E8">
-                <a:alpha val="30000"/>
-              </a:srgbClr>
-            </a:outerShdw>
-          </a:effectLst>
-        </p:spPr>
-      </p:sp>
-      <p:pic>
-        <p:nvPicPr>
-          <p:cNvPr id="352" name="Picture 351" descr="plot_13.png"/>
-          <p:cNvPicPr>
-            <a:picLocks noChangeAspect="1"/>
-          </p:cNvPicPr>
-          <p:nvPr/>
-        </p:nvPicPr>
-        <p:blipFill>
-          <a:blip r:embed="rId3"/>
-          <a:stretch>
-            <a:fillRect/>
-          </a:stretch>
-        </p:blipFill>
-        <p:spPr>
-          <a:xfrm>
-            <a:off x="6309360" y="1721629"/>
-            <a:ext cx="5221224" cy="3451317"/>
-          </a:xfrm>
-          <a:prstGeom prst="rect">
-            <a:avLst/>
-          </a:prstGeom>
-        </p:spPr>
-      </p:pic>
-      <p:sp>
-        <p:nvSpPr>
           <p:cNvPr id="352" name="Text"/>
           <p:cNvSpPr/>
           <p:nvPr/>
@@ -4033,7 +4013,7 @@
         <p:spPr>
           <a:xfrm>
             <a:off x="566928" y="5394960"/>
-            <a:ext cx="5440680" cy="274320"/>
+            <a:ext cx="11073384" cy="274320"/>
           </a:xfrm>
           <a:prstGeom prst="rect">
             <a:avLst/>
@@ -4058,44 +4038,6 @@
                 <a:cs typeface="IBM Plex Sans" pitchFamily="34" charset="-120"/>
               </a:rPr>
               <a:t>KNN: k=1 memorises, gap 0.293. Chosen k=50</a:t>
-            </a:r>
-          </a:p>
-        </p:txBody>
-      </p:sp>
-      <p:sp>
-        <p:nvSpPr>
-          <p:cNvPr id="353" name="Text"/>
-          <p:cNvSpPr/>
-          <p:nvPr/>
-        </p:nvSpPr>
-        <p:spPr>
-          <a:xfrm>
-            <a:off x="6199632" y="5394960"/>
-            <a:ext cx="5440680" cy="274320"/>
-          </a:xfrm>
-          <a:prstGeom prst="rect">
-            <a:avLst/>
-          </a:prstGeom>
-          <a:noFill/>
-          <a:ln/>
-        </p:spPr>
-        <p:txBody>
-          <a:bodyPr wrap="square" lIns="0" tIns="0" rIns="0" bIns="0" rtlCol="0" anchor="ctr"/>
-          <a:lstStyle/>
-          <a:p>
-            <a:pPr indent="0" marL="0" algn="ctr">
-              <a:buNone/>
-            </a:pPr>
-            <a:r>
-              <a:rPr lang="en-US" sz="1200" b="1" kern="0" dirty="0">
-                <a:solidFill>
-                  <a:srgbClr val="522CBA"/>
-                </a:solidFill>
-                <a:latin typeface="IBM Plex Sans" pitchFamily="34" charset="0"/>
-                <a:ea typeface="IBM Plex Sans" pitchFamily="34" charset="-122"/>
-                <a:cs typeface="IBM Plex Sans" pitchFamily="34" charset="-120"/>
-              </a:rPr>
-              <a:t>Decision Tree: validation peaks at depth 4. Chosen 6</a:t>
             </a:r>
           </a:p>
         </p:txBody>
@@ -4699,6 +4641,10 @@
             <a:prstDash val="solid"/>
           </a:ln>
         </p:spPr>
+        <p:txBody>
+          <a:bodyPr/>
+          <a:p/>
+        </p:txBody>
       </p:sp>
       <p:sp>
         <p:nvSpPr>
@@ -4771,17 +4717,21 @@
             </a:outerShdw>
           </a:effectLst>
         </p:spPr>
+        <p:txBody>
+          <a:bodyPr/>
+          <a:p/>
+        </p:txBody>
       </p:sp>
       <p:pic>
         <p:nvPicPr>
-          <p:cNvPr id="371" name="Picture 370" descr="plot_16.png"/>
+          <p:cNvPr id="382" name="Picture 381" descr="slide15_scatter.png"/>
           <p:cNvPicPr>
             <a:picLocks noChangeAspect="1"/>
           </p:cNvPicPr>
           <p:nvPr/>
         </p:nvPicPr>
         <p:blipFill>
-          <a:blip r:embed="rId2"/>
+          <a:blip r:embed="rId3"/>
           <a:stretch>
             <a:fillRect/>
           </a:stretch>
@@ -4829,6 +4779,10 @@
             </a:outerShdw>
           </a:effectLst>
         </p:spPr>
+        <p:txBody>
+          <a:bodyPr/>
+          <a:p/>
+        </p:txBody>
       </p:sp>
       <p:sp>
         <p:nvSpPr>
@@ -4854,6 +4808,10 @@
             <a:prstDash val="solid"/>
           </a:ln>
         </p:spPr>
+        <p:txBody>
+          <a:bodyPr/>
+          <a:p/>
+        </p:txBody>
       </p:sp>
       <p:sp>
         <p:nvSpPr>
@@ -4967,6 +4925,10 @@
             </a:outerShdw>
           </a:effectLst>
         </p:spPr>
+        <p:txBody>
+          <a:bodyPr/>
+          <a:p/>
+        </p:txBody>
       </p:sp>
       <p:sp>
         <p:nvSpPr>
@@ -4992,6 +4954,10 @@
             <a:prstDash val="solid"/>
           </a:ln>
         </p:spPr>
+        <p:txBody>
+          <a:bodyPr/>
+          <a:p/>
+        </p:txBody>
       </p:sp>
       <p:sp>
         <p:nvSpPr>
@@ -5067,7 +5033,7 @@
                 <a:ea typeface="IBM Plex Sans" pitchFamily="34" charset="-122"/>
                 <a:cs typeface="IBM Plex Sans" pitchFamily="34" charset="-120"/>
               </a:rPr>
-              <a:t>Linear Regression. Best test R2 and MAE of all six, because ArrDelay is close to linear in DepDelay.</a:t>
+              <a:t>Linear Regression. Best test R2 and MAE of all four, because ArrDelay is close to linear in DepDelay.</a:t>
             </a:r>
           </a:p>
         </p:txBody>
@@ -5105,6 +5071,10 @@
             </a:outerShdw>
           </a:effectLst>
         </p:spPr>
+        <p:txBody>
+          <a:bodyPr/>
+          <a:p/>
+        </p:txBody>
       </p:sp>
       <p:sp>
         <p:nvSpPr>
@@ -5130,6 +5100,10 @@
             <a:prstDash val="solid"/>
           </a:ln>
         </p:spPr>
+        <p:txBody>
+          <a:bodyPr/>
+          <a:p/>
+        </p:txBody>
       </p:sp>
       <p:sp>
         <p:nvSpPr>
@@ -7940,14 +7914,14 @@
       </p:sp>
       <p:pic>
         <p:nvPicPr>
-          <p:cNvPr id="434" name="Picture 433" descr="plot_21.png"/>
+          <p:cNvPr id="440" name="Picture 439" descr="kdist_plot.png"/>
           <p:cNvPicPr>
             <a:picLocks noChangeAspect="1"/>
           </p:cNvPicPr>
           <p:nvPr/>
         </p:nvPicPr>
         <p:blipFill>
-          <a:blip r:embed="rId2"/>
+          <a:blip r:embed="rId4"/>
           <a:stretch>
             <a:fillRect/>
           </a:stretch>
@@ -7998,14 +7972,14 @@
       </p:sp>
       <p:pic>
         <p:nvPicPr>
-          <p:cNvPr id="435" name="Picture 434" descr="plot_22.png"/>
+          <p:cNvPr id="441" name="Picture 440" descr="arrdelay_plot.png"/>
           <p:cNvPicPr>
             <a:picLocks noChangeAspect="1"/>
           </p:cNvPicPr>
           <p:nvPr/>
         </p:nvPicPr>
         <p:blipFill>
-          <a:blip r:embed="rId3"/>
+          <a:blip r:embed="rId5"/>
           <a:stretch>
             <a:fillRect/>
           </a:stretch>
@@ -8053,7 +8027,7 @@
                 <a:ea typeface="IBM Plex Sans" pitchFamily="34" charset="-122"/>
                 <a:cs typeface="IBM Plex Sans" pitchFamily="34" charset="-120"/>
               </a:rPr>
-              <a:t>BIC keeps falling, so k=4 matches KMeans for comparison</a:t>
+              <a:t>eps=0.90 chosen from the k-distance knee, min_samples=12</a:t>
             </a:r>
           </a:p>
         </p:txBody>
@@ -8091,7 +8065,7 @@
                 <a:ea typeface="IBM Plex Sans" pitchFamily="34" charset="-122"/>
                 <a:cs typeface="IBM Plex Sans" pitchFamily="34" charset="-120"/>
               </a:rPr>
-              <a:t>Cluster 1: TaxiOut 30.7 min, 92% delayed</a:t>
+              <a:t>Noise: TaxiOut 39.1 min, 92% delayed</a:t>
             </a:r>
           </a:p>
         </p:txBody>
@@ -8188,7 +8162,7 @@
                 <a:ea typeface="IBM Plex Sans" pitchFamily="34" charset="-122"/>
                 <a:cs typeface="IBM Plex Sans" pitchFamily="34" charset="-120"/>
               </a:rPr>
-              <a:t>GMM anchors its severe group on ground congestion rather than total delay, so the two only partly agree.</a:t>
+              <a:t>DBSCAN labels 2.3% of flights as noise instead of forcing a cluster count, and agrees with KMeans on about half of its severe delay group.</a:t>
             </a:r>
           </a:p>
         </p:txBody>

</xml_diff>